<commit_message>
Producto B: cortes 2022 (extremo/cola_gorda) + matriz de señales + deck v2
- Comparaciones de portafolio LUZ para 2022-06-30 (extremo) y 2022-03-31
  (cola gorda): ambas NEGATIVA fuerte, FDP predictiva desplazada a la
  izquierda y más ancha que la histórica — el modelo señala el bear market
  de bonos de 2022.
- SENALES.md: matriz completa de 18 señales (3 cortes × portafolio + 5
  índices).
- Deck regenerado con las 3 fechas de portafolio + tabla nativa de señales.
</commit_message>
<xml_diff>
--- a/docs/producto_b/outputs/deck_producto_b_2026-06-16.pptx
+++ b/docs/producto_b/outputs/deck_producto_b_2026-06-16.pptx
@@ -21,6 +21,9 @@
     <p:sldId id="269" r:id="rId20"/>
     <p:sldId id="270" r:id="rId21"/>
     <p:sldId id="271" r:id="rId22"/>
+    <p:sldId id="272" r:id="rId23"/>
+    <p:sldId id="273" r:id="rId24"/>
+    <p:sldId id="274" r:id="rId25"/>
   </p:sldIdLst>
   <p:sldSz cx="12188952" cy="6858000" type="screen4x3"/>
   <p:notesSz cx="6858000" cy="9144000"/>
@@ -3302,57 +3305,14 @@
       <p:grpSpPr/>
       <p:sp>
         <p:nvSpPr>
-          <p:cNvPr id="2" name="Rectangle 1"/>
-          <p:cNvSpPr/>
+          <p:cNvPr id="2" name="TextBox 1"/>
+          <p:cNvSpPr txBox="1"/>
           <p:nvPr/>
         </p:nvSpPr>
         <p:spPr>
           <a:xfrm>
-            <a:off x="0" y="0"/>
-            <a:ext cx="12188952" cy="6858000"/>
-          </a:xfrm>
-          <a:prstGeom prst="rect">
-            <a:avLst/>
-          </a:prstGeom>
-          <a:solidFill>
-            <a:srgbClr val="1A3A5C"/>
-          </a:solidFill>
-          <a:ln>
-            <a:noFill/>
-          </a:ln>
-        </p:spPr>
-        <p:style>
-          <a:lnRef idx="1">
-            <a:schemeClr val="accent1"/>
-          </a:lnRef>
-          <a:fillRef idx="3">
-            <a:schemeClr val="accent1"/>
-          </a:fillRef>
-          <a:effectRef idx="2">
-            <a:schemeClr val="accent1"/>
-          </a:effectRef>
-          <a:fontRef idx="minor">
-            <a:schemeClr val="lt1"/>
-          </a:fontRef>
-        </p:style>
-        <p:txBody>
-          <a:bodyPr rtlCol="0" anchor="ctr"/>
-          <a:lstStyle/>
-          <a:p>
-            <a:pPr algn="ctr"/>
-          </a:p>
-        </p:txBody>
-      </p:sp>
-      <p:sp>
-        <p:nvSpPr>
-          <p:cNvPr id="3" name="TextBox 2"/>
-          <p:cNvSpPr txBox="1"/>
-          <p:nvPr/>
-        </p:nvSpPr>
-        <p:spPr>
-          <a:xfrm>
-            <a:off x="731520" y="2651760"/>
-            <a:ext cx="10725912" cy="1005840"/>
+            <a:off x="365760" y="109728"/>
+            <a:ext cx="11457432" cy="365760"/>
           </a:xfrm>
           <a:prstGeom prst="rect">
             <a:avLst/>
@@ -3367,50 +3327,40 @@
           <a:p>
             <a:pPr algn="l"/>
             <a:r>
-              <a:rPr sz="3400" b="1" i="0">
+              <a:rPr sz="1400" b="1" i="0">
                 <a:solidFill>
-                  <a:srgbClr val="FFFFFF"/>
+                  <a:srgbClr val="1A3A5C"/>
                 </a:solidFill>
               </a:rPr>
-              <a:t>Modelo vs historia — Índices principales</a:t>
-            </a:r>
-          </a:p>
-        </p:txBody>
-      </p:sp>
-      <p:sp>
-        <p:nvSpPr>
-          <p:cNvPr id="4" name="TextBox 3"/>
-          <p:cNvSpPr txBox="1"/>
+              <a:t>Comparación portafolio · luz_portafolio_2022-06-30_h12m</a:t>
+            </a:r>
+          </a:p>
+        </p:txBody>
+      </p:sp>
+      <p:pic>
+        <p:nvPicPr>
+          <p:cNvPr id="3" name="Picture 2" descr="luz_portafolio_2022-06-30_h12m.png"/>
+          <p:cNvPicPr>
+            <a:picLocks noChangeAspect="1"/>
+          </p:cNvPicPr>
           <p:nvPr/>
-        </p:nvSpPr>
+        </p:nvPicPr>
+        <p:blipFill>
+          <a:blip r:embed="rId2"/>
+          <a:stretch>
+            <a:fillRect/>
+          </a:stretch>
+        </p:blipFill>
         <p:spPr>
           <a:xfrm>
-            <a:off x="731520" y="3657600"/>
-            <a:ext cx="10725912" cy="1371600"/>
+            <a:off x="365760" y="548640"/>
+            <a:ext cx="11457432" cy="6658436"/>
           </a:xfrm>
           <a:prstGeom prst="rect">
             <a:avLst/>
           </a:prstGeom>
-          <a:noFill/>
         </p:spPr>
-        <p:txBody>
-          <a:bodyPr wrap="square">
-            <a:spAutoFit/>
-          </a:bodyPr>
-          <a:lstStyle/>
-          <a:p>
-            <a:pPr algn="l"/>
-            <a:r>
-              <a:rPr sz="1800" b="0" i="0">
-                <a:solidFill>
-                  <a:srgbClr val="E8EFF7"/>
-                </a:solidFill>
-              </a:rPr>
-              <a:t>LQD · IGOV · GHYG · EMB · ACWI</a:t>
-            </a:r>
-          </a:p>
-        </p:txBody>
-      </p:sp>
+      </p:pic>
     </p:spTree>
   </p:cSld>
   <p:clrMapOvr>
@@ -3458,14 +3408,14 @@
                   <a:srgbClr val="1A3A5C"/>
                 </a:solidFill>
               </a:rPr>
-              <a:t>Comparación índice · indice_ACWI_2024-06-30_h12m</a:t>
+              <a:t>Comparación portafolio · luz_portafolio_2024-06-30_h12m</a:t>
             </a:r>
           </a:p>
         </p:txBody>
       </p:sp>
       <p:pic>
         <p:nvPicPr>
-          <p:cNvPr id="3" name="Picture 2" descr="indice_ACWI_2024-06-30_h12m.png"/>
+          <p:cNvPr id="3" name="Picture 2" descr="luz_portafolio_2024-06-30_h12m.png"/>
           <p:cNvPicPr>
             <a:picLocks noChangeAspect="1"/>
           </p:cNvPicPr>
@@ -3507,14 +3457,57 @@
       <p:grpSpPr/>
       <p:sp>
         <p:nvSpPr>
-          <p:cNvPr id="2" name="TextBox 1"/>
+          <p:cNvPr id="2" name="Rectangle 1"/>
+          <p:cNvSpPr/>
+          <p:nvPr/>
+        </p:nvSpPr>
+        <p:spPr>
+          <a:xfrm>
+            <a:off x="0" y="0"/>
+            <a:ext cx="12188952" cy="6858000"/>
+          </a:xfrm>
+          <a:prstGeom prst="rect">
+            <a:avLst/>
+          </a:prstGeom>
+          <a:solidFill>
+            <a:srgbClr val="1A3A5C"/>
+          </a:solidFill>
+          <a:ln>
+            <a:noFill/>
+          </a:ln>
+        </p:spPr>
+        <p:style>
+          <a:lnRef idx="1">
+            <a:schemeClr val="accent1"/>
+          </a:lnRef>
+          <a:fillRef idx="3">
+            <a:schemeClr val="accent1"/>
+          </a:fillRef>
+          <a:effectRef idx="2">
+            <a:schemeClr val="accent1"/>
+          </a:effectRef>
+          <a:fontRef idx="minor">
+            <a:schemeClr val="lt1"/>
+          </a:fontRef>
+        </p:style>
+        <p:txBody>
+          <a:bodyPr rtlCol="0" anchor="ctr"/>
+          <a:lstStyle/>
+          <a:p>
+            <a:pPr algn="ctr"/>
+          </a:p>
+        </p:txBody>
+      </p:sp>
+      <p:sp>
+        <p:nvSpPr>
+          <p:cNvPr id="3" name="TextBox 2"/>
           <p:cNvSpPr txBox="1"/>
           <p:nvPr/>
         </p:nvSpPr>
         <p:spPr>
           <a:xfrm>
-            <a:off x="365760" y="109728"/>
-            <a:ext cx="11457432" cy="365760"/>
+            <a:off x="731520" y="2651760"/>
+            <a:ext cx="10725912" cy="1005840"/>
           </a:xfrm>
           <a:prstGeom prst="rect">
             <a:avLst/>
@@ -3529,40 +3522,50 @@
           <a:p>
             <a:pPr algn="l"/>
             <a:r>
-              <a:rPr sz="1400" b="1" i="0">
+              <a:rPr sz="3400" b="1" i="0">
                 <a:solidFill>
-                  <a:srgbClr val="1A3A5C"/>
+                  <a:srgbClr val="FFFFFF"/>
                 </a:solidFill>
               </a:rPr>
-              <a:t>Comparación índice · indice_EMB_2024-06-30_h12m</a:t>
-            </a:r>
-          </a:p>
-        </p:txBody>
-      </p:sp>
-      <p:pic>
-        <p:nvPicPr>
-          <p:cNvPr id="3" name="Picture 2" descr="indice_EMB_2024-06-30_h12m.png"/>
-          <p:cNvPicPr>
-            <a:picLocks noChangeAspect="1"/>
-          </p:cNvPicPr>
+              <a:t>Modelo vs historia — Índices principales</a:t>
+            </a:r>
+          </a:p>
+        </p:txBody>
+      </p:sp>
+      <p:sp>
+        <p:nvSpPr>
+          <p:cNvPr id="4" name="TextBox 3"/>
+          <p:cNvSpPr txBox="1"/>
           <p:nvPr/>
-        </p:nvPicPr>
-        <p:blipFill>
-          <a:blip r:embed="rId2"/>
-          <a:stretch>
-            <a:fillRect/>
-          </a:stretch>
-        </p:blipFill>
+        </p:nvSpPr>
         <p:spPr>
           <a:xfrm>
-            <a:off x="365760" y="548640"/>
-            <a:ext cx="11457432" cy="6658436"/>
+            <a:off x="731520" y="3657600"/>
+            <a:ext cx="10725912" cy="1371600"/>
           </a:xfrm>
           <a:prstGeom prst="rect">
             <a:avLst/>
           </a:prstGeom>
+          <a:noFill/>
         </p:spPr>
-      </p:pic>
+        <p:txBody>
+          <a:bodyPr wrap="square">
+            <a:spAutoFit/>
+          </a:bodyPr>
+          <a:lstStyle/>
+          <a:p>
+            <a:pPr algn="l"/>
+            <a:r>
+              <a:rPr sz="1800" b="0" i="0">
+                <a:solidFill>
+                  <a:srgbClr val="E8EFF7"/>
+                </a:solidFill>
+              </a:rPr>
+              <a:t>LQD · IGOV · GHYG · EMB · ACWI</a:t>
+            </a:r>
+          </a:p>
+        </p:txBody>
+      </p:sp>
     </p:spTree>
   </p:cSld>
   <p:clrMapOvr>
@@ -3610,14 +3613,14 @@
                   <a:srgbClr val="1A3A5C"/>
                 </a:solidFill>
               </a:rPr>
-              <a:t>Comparación índice · indice_GHYG_2024-06-30_h12m</a:t>
+              <a:t>Comparación índice · indice_ACWI_2024-06-30_h12m</a:t>
             </a:r>
           </a:p>
         </p:txBody>
       </p:sp>
       <p:pic>
         <p:nvPicPr>
-          <p:cNvPr id="3" name="Picture 2" descr="indice_GHYG_2024-06-30_h12m.png"/>
+          <p:cNvPr id="3" name="Picture 2" descr="indice_ACWI_2024-06-30_h12m.png"/>
           <p:cNvPicPr>
             <a:picLocks noChangeAspect="1"/>
           </p:cNvPicPr>
@@ -3686,14 +3689,14 @@
                   <a:srgbClr val="1A3A5C"/>
                 </a:solidFill>
               </a:rPr>
-              <a:t>Comparación índice · indice_IGOV_2024-06-30_h12m</a:t>
+              <a:t>Comparación índice · indice_EMB_2024-06-30_h12m</a:t>
             </a:r>
           </a:p>
         </p:txBody>
       </p:sp>
       <p:pic>
         <p:nvPicPr>
-          <p:cNvPr id="3" name="Picture 2" descr="indice_IGOV_2024-06-30_h12m.png"/>
+          <p:cNvPr id="3" name="Picture 2" descr="indice_EMB_2024-06-30_h12m.png"/>
           <p:cNvPicPr>
             <a:picLocks noChangeAspect="1"/>
           </p:cNvPicPr>
@@ -3762,6 +3765,158 @@
                   <a:srgbClr val="1A3A5C"/>
                 </a:solidFill>
               </a:rPr>
+              <a:t>Comparación índice · indice_GHYG_2024-06-30_h12m</a:t>
+            </a:r>
+          </a:p>
+        </p:txBody>
+      </p:sp>
+      <p:pic>
+        <p:nvPicPr>
+          <p:cNvPr id="3" name="Picture 2" descr="indice_GHYG_2024-06-30_h12m.png"/>
+          <p:cNvPicPr>
+            <a:picLocks noChangeAspect="1"/>
+          </p:cNvPicPr>
+          <p:nvPr/>
+        </p:nvPicPr>
+        <p:blipFill>
+          <a:blip r:embed="rId2"/>
+          <a:stretch>
+            <a:fillRect/>
+          </a:stretch>
+        </p:blipFill>
+        <p:spPr>
+          <a:xfrm>
+            <a:off x="365760" y="548640"/>
+            <a:ext cx="11457432" cy="6658436"/>
+          </a:xfrm>
+          <a:prstGeom prst="rect">
+            <a:avLst/>
+          </a:prstGeom>
+        </p:spPr>
+      </p:pic>
+    </p:spTree>
+  </p:cSld>
+  <p:clrMapOvr>
+    <a:masterClrMapping/>
+  </p:clrMapOvr>
+</p:sld>
+</file>
+
+<file path=ppt/slides/slide16.xml><?xml version="1.0" encoding="utf-8"?>
+<p:sld xmlns:a="http://schemas.openxmlformats.org/drawingml/2006/main" xmlns:p="http://schemas.openxmlformats.org/presentationml/2006/main" xmlns:r="http://schemas.openxmlformats.org/officeDocument/2006/relationships">
+  <p:cSld>
+    <p:spTree>
+      <p:nvGrpSpPr>
+        <p:cNvPr id="1" name=""/>
+        <p:cNvGrpSpPr/>
+        <p:nvPr/>
+      </p:nvGrpSpPr>
+      <p:grpSpPr/>
+      <p:sp>
+        <p:nvSpPr>
+          <p:cNvPr id="2" name="TextBox 1"/>
+          <p:cNvSpPr txBox="1"/>
+          <p:nvPr/>
+        </p:nvSpPr>
+        <p:spPr>
+          <a:xfrm>
+            <a:off x="365760" y="109728"/>
+            <a:ext cx="11457432" cy="365760"/>
+          </a:xfrm>
+          <a:prstGeom prst="rect">
+            <a:avLst/>
+          </a:prstGeom>
+          <a:noFill/>
+        </p:spPr>
+        <p:txBody>
+          <a:bodyPr wrap="square">
+            <a:spAutoFit/>
+          </a:bodyPr>
+          <a:lstStyle/>
+          <a:p>
+            <a:pPr algn="l"/>
+            <a:r>
+              <a:rPr sz="1400" b="1" i="0">
+                <a:solidFill>
+                  <a:srgbClr val="1A3A5C"/>
+                </a:solidFill>
+              </a:rPr>
+              <a:t>Comparación índice · indice_IGOV_2024-06-30_h12m</a:t>
+            </a:r>
+          </a:p>
+        </p:txBody>
+      </p:sp>
+      <p:pic>
+        <p:nvPicPr>
+          <p:cNvPr id="3" name="Picture 2" descr="indice_IGOV_2024-06-30_h12m.png"/>
+          <p:cNvPicPr>
+            <a:picLocks noChangeAspect="1"/>
+          </p:cNvPicPr>
+          <p:nvPr/>
+        </p:nvPicPr>
+        <p:blipFill>
+          <a:blip r:embed="rId2"/>
+          <a:stretch>
+            <a:fillRect/>
+          </a:stretch>
+        </p:blipFill>
+        <p:spPr>
+          <a:xfrm>
+            <a:off x="365760" y="548640"/>
+            <a:ext cx="11457432" cy="6658436"/>
+          </a:xfrm>
+          <a:prstGeom prst="rect">
+            <a:avLst/>
+          </a:prstGeom>
+        </p:spPr>
+      </p:pic>
+    </p:spTree>
+  </p:cSld>
+  <p:clrMapOvr>
+    <a:masterClrMapping/>
+  </p:clrMapOvr>
+</p:sld>
+</file>
+
+<file path=ppt/slides/slide17.xml><?xml version="1.0" encoding="utf-8"?>
+<p:sld xmlns:a="http://schemas.openxmlformats.org/drawingml/2006/main" xmlns:p="http://schemas.openxmlformats.org/presentationml/2006/main" xmlns:r="http://schemas.openxmlformats.org/officeDocument/2006/relationships">
+  <p:cSld>
+    <p:spTree>
+      <p:nvGrpSpPr>
+        <p:cNvPr id="1" name=""/>
+        <p:cNvGrpSpPr/>
+        <p:nvPr/>
+      </p:nvGrpSpPr>
+      <p:grpSpPr/>
+      <p:sp>
+        <p:nvSpPr>
+          <p:cNvPr id="2" name="TextBox 1"/>
+          <p:cNvSpPr txBox="1"/>
+          <p:nvPr/>
+        </p:nvSpPr>
+        <p:spPr>
+          <a:xfrm>
+            <a:off x="365760" y="109728"/>
+            <a:ext cx="11457432" cy="365760"/>
+          </a:xfrm>
+          <a:prstGeom prst="rect">
+            <a:avLst/>
+          </a:prstGeom>
+          <a:noFill/>
+        </p:spPr>
+        <p:txBody>
+          <a:bodyPr wrap="square">
+            <a:spAutoFit/>
+          </a:bodyPr>
+          <a:lstStyle/>
+          <a:p>
+            <a:pPr algn="l"/>
+            <a:r>
+              <a:rPr sz="1400" b="1" i="0">
+                <a:solidFill>
+                  <a:srgbClr val="1A3A5C"/>
+                </a:solidFill>
+              </a:rPr>
               <a:t>Comparación índice · indice_LQD_2024-06-30_h12m</a:t>
             </a:r>
           </a:p>
@@ -3799,7 +3954,2011 @@
 </p:sld>
 </file>
 
-<file path=ppt/slides/slide16.xml><?xml version="1.0" encoding="utf-8"?>
+<file path=ppt/slides/slide18.xml><?xml version="1.0" encoding="utf-8"?>
+<p:sld xmlns:a="http://schemas.openxmlformats.org/drawingml/2006/main" xmlns:p="http://schemas.openxmlformats.org/presentationml/2006/main" xmlns:r="http://schemas.openxmlformats.org/officeDocument/2006/relationships">
+  <p:cSld>
+    <p:spTree>
+      <p:nvGrpSpPr>
+        <p:cNvPr id="1" name=""/>
+        <p:cNvGrpSpPr/>
+        <p:nvPr/>
+      </p:nvGrpSpPr>
+      <p:grpSpPr/>
+      <p:sp>
+        <p:nvSpPr>
+          <p:cNvPr id="2" name="TextBox 1"/>
+          <p:cNvSpPr txBox="1"/>
+          <p:nvPr/>
+        </p:nvSpPr>
+        <p:spPr>
+          <a:xfrm>
+            <a:off x="640080" y="365760"/>
+            <a:ext cx="10908792" cy="640080"/>
+          </a:xfrm>
+          <a:prstGeom prst="rect">
+            <a:avLst/>
+          </a:prstGeom>
+          <a:noFill/>
+        </p:spPr>
+        <p:txBody>
+          <a:bodyPr wrap="square">
+            <a:spAutoFit/>
+          </a:bodyPr>
+          <a:lstStyle/>
+          <a:p>
+            <a:pPr algn="l"/>
+            <a:r>
+              <a:rPr sz="2600" b="1" i="0">
+                <a:solidFill>
+                  <a:srgbClr val="1A3A5C"/>
+                </a:solidFill>
+              </a:rPr>
+              <a:t>Matriz de señales — modelo vs historia</a:t>
+            </a:r>
+          </a:p>
+        </p:txBody>
+      </p:sp>
+      <p:graphicFrame>
+        <p:nvGraphicFramePr>
+          <p:cNvPr id="3" name="Table 2"/>
+          <p:cNvGraphicFramePr>
+            <a:graphicFrameLocks noGrp="1"/>
+          </p:cNvGraphicFramePr>
+          <p:nvPr/>
+        </p:nvGraphicFramePr>
+        <p:xfrm>
+          <a:off x="548640" y="1280160"/>
+          <a:ext cx="11091672" cy="4572000"/>
+        </p:xfrm>
+        <a:graphic>
+          <a:graphicData uri="http://schemas.openxmlformats.org/drawingml/2006/table">
+            <a:tbl>
+              <a:tblPr firstRow="1" bandRow="1">
+                <a:tableStyleId>{5C22544A-7EE6-4342-B048-85BDC9FD1C3A}</a:tableStyleId>
+              </a:tblPr>
+              <a:tblGrid>
+                <a:gridCol w="1584524"/>
+                <a:gridCol w="1584524"/>
+                <a:gridCol w="1584524"/>
+                <a:gridCol w="1584524"/>
+                <a:gridCol w="1584524"/>
+                <a:gridCol w="1584524"/>
+                <a:gridCol w="1584528"/>
+              </a:tblGrid>
+              <a:tr h="240631">
+                <a:tc>
+                  <a:txBody>
+                    <a:bodyPr/>
+                    <a:lstStyle/>
+                    <a:p>
+                      <a:r>
+                        <a:rPr sz="1200" b="1">
+                          <a:solidFill>
+                            <a:srgbClr val="FFFFFF"/>
+                          </a:solidFill>
+                        </a:rPr>
+                        <a:t>Activo</a:t>
+                      </a:r>
+                    </a:p>
+                  </a:txBody>
+                  <a:tcPr>
+                    <a:solidFill>
+                      <a:srgbClr val="2A6FB3"/>
+                    </a:solidFill>
+                  </a:tcPr>
+                </a:tc>
+                <a:tc>
+                  <a:txBody>
+                    <a:bodyPr/>
+                    <a:lstStyle/>
+                    <a:p>
+                      <a:r>
+                        <a:rPr sz="1200" b="1">
+                          <a:solidFill>
+                            <a:srgbClr val="FFFFFF"/>
+                          </a:solidFill>
+                        </a:rPr>
+                        <a:t>as_of</a:t>
+                      </a:r>
+                    </a:p>
+                  </a:txBody>
+                  <a:tcPr>
+                    <a:solidFill>
+                      <a:srgbClr val="2A6FB3"/>
+                    </a:solidFill>
+                  </a:tcPr>
+                </a:tc>
+                <a:tc>
+                  <a:txBody>
+                    <a:bodyPr/>
+                    <a:lstStyle/>
+                    <a:p>
+                      <a:r>
+                        <a:rPr sz="1200" b="1">
+                          <a:solidFill>
+                            <a:srgbClr val="FFFFFF"/>
+                          </a:solidFill>
+                        </a:rPr>
+                        <a:t>régimen</a:t>
+                      </a:r>
+                    </a:p>
+                  </a:txBody>
+                  <a:tcPr>
+                    <a:solidFill>
+                      <a:srgbClr val="2A6FB3"/>
+                    </a:solidFill>
+                  </a:tcPr>
+                </a:tc>
+                <a:tc>
+                  <a:txBody>
+                    <a:bodyPr/>
+                    <a:lstStyle/>
+                    <a:p>
+                      <a:r>
+                        <a:rPr sz="1200" b="1">
+                          <a:solidFill>
+                            <a:srgbClr val="FFFFFF"/>
+                          </a:solidFill>
+                        </a:rPr>
+                        <a:t>Señal</a:t>
+                      </a:r>
+                    </a:p>
+                  </a:txBody>
+                  <a:tcPr>
+                    <a:solidFill>
+                      <a:srgbClr val="2A6FB3"/>
+                    </a:solidFill>
+                  </a:tcPr>
+                </a:tc>
+                <a:tc>
+                  <a:txBody>
+                    <a:bodyPr/>
+                    <a:lstStyle/>
+                    <a:p>
+                      <a:r>
+                        <a:rPr sz="1200" b="1">
+                          <a:solidFill>
+                            <a:srgbClr val="FFFFFF"/>
+                          </a:solidFill>
+                        </a:rPr>
+                        <a:t>Centro Δbps</a:t>
+                      </a:r>
+                    </a:p>
+                  </a:txBody>
+                  <a:tcPr>
+                    <a:solidFill>
+                      <a:srgbClr val="2A6FB3"/>
+                    </a:solidFill>
+                  </a:tcPr>
+                </a:tc>
+                <a:tc>
+                  <a:txBody>
+                    <a:bodyPr/>
+                    <a:lstStyle/>
+                    <a:p>
+                      <a:r>
+                        <a:rPr sz="1200" b="1">
+                          <a:solidFill>
+                            <a:srgbClr val="FFFFFF"/>
+                          </a:solidFill>
+                        </a:rPr>
+                        <a:t>Ancho HDI50 (×)</a:t>
+                      </a:r>
+                    </a:p>
+                  </a:txBody>
+                  <a:tcPr>
+                    <a:solidFill>
+                      <a:srgbClr val="2A6FB3"/>
+                    </a:solidFill>
+                  </a:tcPr>
+                </a:tc>
+                <a:tc>
+                  <a:txBody>
+                    <a:bodyPr/>
+                    <a:lstStyle/>
+                    <a:p>
+                      <a:r>
+                        <a:rPr sz="1200" b="1">
+                          <a:solidFill>
+                            <a:srgbClr val="FFFFFF"/>
+                          </a:solidFill>
+                        </a:rPr>
+                        <a:t>Riesgo Δbps</a:t>
+                      </a:r>
+                    </a:p>
+                  </a:txBody>
+                  <a:tcPr>
+                    <a:solidFill>
+                      <a:srgbClr val="2A6FB3"/>
+                    </a:solidFill>
+                  </a:tcPr>
+                </a:tc>
+              </a:tr>
+              <a:tr h="240631">
+                <a:tc>
+                  <a:txBody>
+                    <a:bodyPr/>
+                    <a:lstStyle/>
+                    <a:p>
+                      <a:r>
+                        <a:rPr sz="1100"/>
+                        <a:t>Portafolio LUZ</a:t>
+                      </a:r>
+                    </a:p>
+                  </a:txBody>
+                  <a:tcPr/>
+                </a:tc>
+                <a:tc>
+                  <a:txBody>
+                    <a:bodyPr/>
+                    <a:lstStyle/>
+                    <a:p>
+                      <a:r>
+                        <a:rPr sz="1100"/>
+                        <a:t>2024-06-30</a:t>
+                      </a:r>
+                    </a:p>
+                  </a:txBody>
+                  <a:tcPr/>
+                </a:tc>
+                <a:tc>
+                  <a:txBody>
+                    <a:bodyPr/>
+                    <a:lstStyle/>
+                    <a:p>
+                      <a:r>
+                        <a:rPr sz="1100"/>
+                        <a:t>normal</a:t>
+                      </a:r>
+                    </a:p>
+                  </a:txBody>
+                  <a:tcPr/>
+                </a:tc>
+                <a:tc>
+                  <a:txBody>
+                    <a:bodyPr/>
+                    <a:lstStyle/>
+                    <a:p>
+                      <a:r>
+                        <a:rPr sz="1100"/>
+                        <a:t>NEUTRAL neutral</a:t>
+                      </a:r>
+                    </a:p>
+                  </a:txBody>
+                  <a:tcPr/>
+                </a:tc>
+                <a:tc>
+                  <a:txBody>
+                    <a:bodyPr/>
+                    <a:lstStyle/>
+                    <a:p>
+                      <a:r>
+                        <a:rPr sz="1100"/>
+                        <a:t>-1</a:t>
+                      </a:r>
+                    </a:p>
+                  </a:txBody>
+                  <a:tcPr/>
+                </a:tc>
+                <a:tc>
+                  <a:txBody>
+                    <a:bodyPr/>
+                    <a:lstStyle/>
+                    <a:p>
+                      <a:r>
+                        <a:rPr sz="1100"/>
+                        <a:t>0.93</a:t>
+                      </a:r>
+                    </a:p>
+                  </a:txBody>
+                  <a:tcPr/>
+                </a:tc>
+                <a:tc>
+                  <a:txBody>
+                    <a:bodyPr/>
+                    <a:lstStyle/>
+                    <a:p>
+                      <a:r>
+                        <a:rPr sz="1100"/>
+                        <a:t>+847</a:t>
+                      </a:r>
+                    </a:p>
+                  </a:txBody>
+                  <a:tcPr/>
+                </a:tc>
+              </a:tr>
+              <a:tr h="240631">
+                <a:tc>
+                  <a:txBody>
+                    <a:bodyPr/>
+                    <a:lstStyle/>
+                    <a:p>
+                      <a:r>
+                        <a:rPr sz="1100"/>
+                        <a:t>LQD</a:t>
+                      </a:r>
+                    </a:p>
+                  </a:txBody>
+                  <a:tcPr/>
+                </a:tc>
+                <a:tc>
+                  <a:txBody>
+                    <a:bodyPr/>
+                    <a:lstStyle/>
+                    <a:p>
+                      <a:r>
+                        <a:rPr sz="1100"/>
+                        <a:t>2024-06-30</a:t>
+                      </a:r>
+                    </a:p>
+                  </a:txBody>
+                  <a:tcPr/>
+                </a:tc>
+                <a:tc>
+                  <a:txBody>
+                    <a:bodyPr/>
+                    <a:lstStyle/>
+                    <a:p>
+                      <a:r>
+                        <a:rPr sz="1100"/>
+                        <a:t>normal</a:t>
+                      </a:r>
+                    </a:p>
+                  </a:txBody>
+                  <a:tcPr/>
+                </a:tc>
+                <a:tc>
+                  <a:txBody>
+                    <a:bodyPr/>
+                    <a:lstStyle/>
+                    <a:p>
+                      <a:r>
+                        <a:rPr sz="1100"/>
+                        <a:t>POSITIVA leve</a:t>
+                      </a:r>
+                    </a:p>
+                  </a:txBody>
+                  <a:tcPr>
+                    <a:solidFill>
+                      <a:srgbClr val="DFF0DF"/>
+                    </a:solidFill>
+                  </a:tcPr>
+                </a:tc>
+                <a:tc>
+                  <a:txBody>
+                    <a:bodyPr/>
+                    <a:lstStyle/>
+                    <a:p>
+                      <a:r>
+                        <a:rPr sz="1100"/>
+                        <a:t>+78</a:t>
+                      </a:r>
+                    </a:p>
+                  </a:txBody>
+                  <a:tcPr/>
+                </a:tc>
+                <a:tc>
+                  <a:txBody>
+                    <a:bodyPr/>
+                    <a:lstStyle/>
+                    <a:p>
+                      <a:r>
+                        <a:rPr sz="1100"/>
+                        <a:t>0.74</a:t>
+                      </a:r>
+                    </a:p>
+                  </a:txBody>
+                  <a:tcPr/>
+                </a:tc>
+                <a:tc>
+                  <a:txBody>
+                    <a:bodyPr/>
+                    <a:lstStyle/>
+                    <a:p>
+                      <a:r>
+                        <a:rPr sz="1100"/>
+                        <a:t>+547</a:t>
+                      </a:r>
+                    </a:p>
+                  </a:txBody>
+                  <a:tcPr/>
+                </a:tc>
+              </a:tr>
+              <a:tr h="240631">
+                <a:tc>
+                  <a:txBody>
+                    <a:bodyPr/>
+                    <a:lstStyle/>
+                    <a:p>
+                      <a:r>
+                        <a:rPr sz="1100"/>
+                        <a:t>IGOV</a:t>
+                      </a:r>
+                    </a:p>
+                  </a:txBody>
+                  <a:tcPr/>
+                </a:tc>
+                <a:tc>
+                  <a:txBody>
+                    <a:bodyPr/>
+                    <a:lstStyle/>
+                    <a:p>
+                      <a:r>
+                        <a:rPr sz="1100"/>
+                        <a:t>2024-06-30</a:t>
+                      </a:r>
+                    </a:p>
+                  </a:txBody>
+                  <a:tcPr/>
+                </a:tc>
+                <a:tc>
+                  <a:txBody>
+                    <a:bodyPr/>
+                    <a:lstStyle/>
+                    <a:p>
+                      <a:r>
+                        <a:rPr sz="1100"/>
+                        <a:t>normal</a:t>
+                      </a:r>
+                    </a:p>
+                  </a:txBody>
+                  <a:tcPr/>
+                </a:tc>
+                <a:tc>
+                  <a:txBody>
+                    <a:bodyPr/>
+                    <a:lstStyle/>
+                    <a:p>
+                      <a:r>
+                        <a:rPr sz="1100"/>
+                        <a:t>NEUTRAL neutral</a:t>
+                      </a:r>
+                    </a:p>
+                  </a:txBody>
+                  <a:tcPr/>
+                </a:tc>
+                <a:tc>
+                  <a:txBody>
+                    <a:bodyPr/>
+                    <a:lstStyle/>
+                    <a:p>
+                      <a:r>
+                        <a:rPr sz="1100"/>
+                        <a:t>+38</a:t>
+                      </a:r>
+                    </a:p>
+                  </a:txBody>
+                  <a:tcPr/>
+                </a:tc>
+                <a:tc>
+                  <a:txBody>
+                    <a:bodyPr/>
+                    <a:lstStyle/>
+                    <a:p>
+                      <a:r>
+                        <a:rPr sz="1100"/>
+                        <a:t>0.61</a:t>
+                      </a:r>
+                    </a:p>
+                  </a:txBody>
+                  <a:tcPr/>
+                </a:tc>
+                <a:tc>
+                  <a:txBody>
+                    <a:bodyPr/>
+                    <a:lstStyle/>
+                    <a:p>
+                      <a:r>
+                        <a:rPr sz="1100"/>
+                        <a:t>+859</a:t>
+                      </a:r>
+                    </a:p>
+                  </a:txBody>
+                  <a:tcPr/>
+                </a:tc>
+              </a:tr>
+              <a:tr h="240631">
+                <a:tc>
+                  <a:txBody>
+                    <a:bodyPr/>
+                    <a:lstStyle/>
+                    <a:p>
+                      <a:r>
+                        <a:rPr sz="1100"/>
+                        <a:t>GHYG</a:t>
+                      </a:r>
+                    </a:p>
+                  </a:txBody>
+                  <a:tcPr/>
+                </a:tc>
+                <a:tc>
+                  <a:txBody>
+                    <a:bodyPr/>
+                    <a:lstStyle/>
+                    <a:p>
+                      <a:r>
+                        <a:rPr sz="1100"/>
+                        <a:t>2024-06-30</a:t>
+                      </a:r>
+                    </a:p>
+                  </a:txBody>
+                  <a:tcPr/>
+                </a:tc>
+                <a:tc>
+                  <a:txBody>
+                    <a:bodyPr/>
+                    <a:lstStyle/>
+                    <a:p>
+                      <a:r>
+                        <a:rPr sz="1100"/>
+                        <a:t>normal</a:t>
+                      </a:r>
+                    </a:p>
+                  </a:txBody>
+                  <a:tcPr/>
+                </a:tc>
+                <a:tc>
+                  <a:txBody>
+                    <a:bodyPr/>
+                    <a:lstStyle/>
+                    <a:p>
+                      <a:r>
+                        <a:rPr sz="1100"/>
+                        <a:t>POSITIVA fuerte</a:t>
+                      </a:r>
+                    </a:p>
+                  </a:txBody>
+                  <a:tcPr>
+                    <a:solidFill>
+                      <a:srgbClr val="DFF0DF"/>
+                    </a:solidFill>
+                  </a:tcPr>
+                </a:tc>
+                <a:tc>
+                  <a:txBody>
+                    <a:bodyPr/>
+                    <a:lstStyle/>
+                    <a:p>
+                      <a:r>
+                        <a:rPr sz="1100"/>
+                        <a:t>+381</a:t>
+                      </a:r>
+                    </a:p>
+                  </a:txBody>
+                  <a:tcPr/>
+                </a:tc>
+                <a:tc>
+                  <a:txBody>
+                    <a:bodyPr/>
+                    <a:lstStyle/>
+                    <a:p>
+                      <a:r>
+                        <a:rPr sz="1100"/>
+                        <a:t>0.74</a:t>
+                      </a:r>
+                    </a:p>
+                  </a:txBody>
+                  <a:tcPr/>
+                </a:tc>
+                <a:tc>
+                  <a:txBody>
+                    <a:bodyPr/>
+                    <a:lstStyle/>
+                    <a:p>
+                      <a:r>
+                        <a:rPr sz="1100"/>
+                        <a:t>+707</a:t>
+                      </a:r>
+                    </a:p>
+                  </a:txBody>
+                  <a:tcPr/>
+                </a:tc>
+              </a:tr>
+              <a:tr h="240631">
+                <a:tc>
+                  <a:txBody>
+                    <a:bodyPr/>
+                    <a:lstStyle/>
+                    <a:p>
+                      <a:r>
+                        <a:rPr sz="1100"/>
+                        <a:t>EMB</a:t>
+                      </a:r>
+                    </a:p>
+                  </a:txBody>
+                  <a:tcPr/>
+                </a:tc>
+                <a:tc>
+                  <a:txBody>
+                    <a:bodyPr/>
+                    <a:lstStyle/>
+                    <a:p>
+                      <a:r>
+                        <a:rPr sz="1100"/>
+                        <a:t>2024-06-30</a:t>
+                      </a:r>
+                    </a:p>
+                  </a:txBody>
+                  <a:tcPr/>
+                </a:tc>
+                <a:tc>
+                  <a:txBody>
+                    <a:bodyPr/>
+                    <a:lstStyle/>
+                    <a:p>
+                      <a:r>
+                        <a:rPr sz="1100"/>
+                        <a:t>normal</a:t>
+                      </a:r>
+                    </a:p>
+                  </a:txBody>
+                  <a:tcPr/>
+                </a:tc>
+                <a:tc>
+                  <a:txBody>
+                    <a:bodyPr/>
+                    <a:lstStyle/>
+                    <a:p>
+                      <a:r>
+                        <a:rPr sz="1100"/>
+                        <a:t>POSITIVA moderada</a:t>
+                      </a:r>
+                    </a:p>
+                  </a:txBody>
+                  <a:tcPr>
+                    <a:solidFill>
+                      <a:srgbClr val="DFF0DF"/>
+                    </a:solidFill>
+                  </a:tcPr>
+                </a:tc>
+                <a:tc>
+                  <a:txBody>
+                    <a:bodyPr/>
+                    <a:lstStyle/>
+                    <a:p>
+                      <a:r>
+                        <a:rPr sz="1100"/>
+                        <a:t>+164</a:t>
+                      </a:r>
+                    </a:p>
+                  </a:txBody>
+                  <a:tcPr/>
+                </a:tc>
+                <a:tc>
+                  <a:txBody>
+                    <a:bodyPr/>
+                    <a:lstStyle/>
+                    <a:p>
+                      <a:r>
+                        <a:rPr sz="1100"/>
+                        <a:t>0.68</a:t>
+                      </a:r>
+                    </a:p>
+                  </a:txBody>
+                  <a:tcPr/>
+                </a:tc>
+                <a:tc>
+                  <a:txBody>
+                    <a:bodyPr/>
+                    <a:lstStyle/>
+                    <a:p>
+                      <a:r>
+                        <a:rPr sz="1100"/>
+                        <a:t>+361</a:t>
+                      </a:r>
+                    </a:p>
+                  </a:txBody>
+                  <a:tcPr/>
+                </a:tc>
+              </a:tr>
+              <a:tr h="240631">
+                <a:tc>
+                  <a:txBody>
+                    <a:bodyPr/>
+                    <a:lstStyle/>
+                    <a:p>
+                      <a:r>
+                        <a:rPr sz="1100"/>
+                        <a:t>ACWI</a:t>
+                      </a:r>
+                    </a:p>
+                  </a:txBody>
+                  <a:tcPr/>
+                </a:tc>
+                <a:tc>
+                  <a:txBody>
+                    <a:bodyPr/>
+                    <a:lstStyle/>
+                    <a:p>
+                      <a:r>
+                        <a:rPr sz="1100"/>
+                        <a:t>2024-06-30</a:t>
+                      </a:r>
+                    </a:p>
+                  </a:txBody>
+                  <a:tcPr/>
+                </a:tc>
+                <a:tc>
+                  <a:txBody>
+                    <a:bodyPr/>
+                    <a:lstStyle/>
+                    <a:p>
+                      <a:r>
+                        <a:rPr sz="1100"/>
+                        <a:t>normal</a:t>
+                      </a:r>
+                    </a:p>
+                  </a:txBody>
+                  <a:tcPr/>
+                </a:tc>
+                <a:tc>
+                  <a:txBody>
+                    <a:bodyPr/>
+                    <a:lstStyle/>
+                    <a:p>
+                      <a:r>
+                        <a:rPr sz="1100"/>
+                        <a:t>POSITIVA fuerte</a:t>
+                      </a:r>
+                    </a:p>
+                  </a:txBody>
+                  <a:tcPr>
+                    <a:solidFill>
+                      <a:srgbClr val="DFF0DF"/>
+                    </a:solidFill>
+                  </a:tcPr>
+                </a:tc>
+                <a:tc>
+                  <a:txBody>
+                    <a:bodyPr/>
+                    <a:lstStyle/>
+                    <a:p>
+                      <a:r>
+                        <a:rPr sz="1100"/>
+                        <a:t>+339</a:t>
+                      </a:r>
+                    </a:p>
+                  </a:txBody>
+                  <a:tcPr/>
+                </a:tc>
+                <a:tc>
+                  <a:txBody>
+                    <a:bodyPr/>
+                    <a:lstStyle/>
+                    <a:p>
+                      <a:r>
+                        <a:rPr sz="1100"/>
+                        <a:t>0.61</a:t>
+                      </a:r>
+                    </a:p>
+                  </a:txBody>
+                  <a:tcPr/>
+                </a:tc>
+                <a:tc>
+                  <a:txBody>
+                    <a:bodyPr/>
+                    <a:lstStyle/>
+                    <a:p>
+                      <a:r>
+                        <a:rPr sz="1100"/>
+                        <a:t>+677</a:t>
+                      </a:r>
+                    </a:p>
+                  </a:txBody>
+                  <a:tcPr/>
+                </a:tc>
+              </a:tr>
+              <a:tr h="240631">
+                <a:tc>
+                  <a:txBody>
+                    <a:bodyPr/>
+                    <a:lstStyle/>
+                    <a:p>
+                      <a:r>
+                        <a:rPr sz="1100"/>
+                        <a:t>Portafolio LUZ</a:t>
+                      </a:r>
+                    </a:p>
+                  </a:txBody>
+                  <a:tcPr/>
+                </a:tc>
+                <a:tc>
+                  <a:txBody>
+                    <a:bodyPr/>
+                    <a:lstStyle/>
+                    <a:p>
+                      <a:r>
+                        <a:rPr sz="1100"/>
+                        <a:t>2022-06-30</a:t>
+                      </a:r>
+                    </a:p>
+                  </a:txBody>
+                  <a:tcPr/>
+                </a:tc>
+                <a:tc>
+                  <a:txBody>
+                    <a:bodyPr/>
+                    <a:lstStyle/>
+                    <a:p>
+                      <a:r>
+                        <a:rPr sz="1100"/>
+                        <a:t>extremo</a:t>
+                      </a:r>
+                    </a:p>
+                  </a:txBody>
+                  <a:tcPr/>
+                </a:tc>
+                <a:tc>
+                  <a:txBody>
+                    <a:bodyPr/>
+                    <a:lstStyle/>
+                    <a:p>
+                      <a:r>
+                        <a:rPr sz="1100"/>
+                        <a:t>NEGATIVA fuerte</a:t>
+                      </a:r>
+                    </a:p>
+                  </a:txBody>
+                  <a:tcPr>
+                    <a:solidFill>
+                      <a:srgbClr val="F6DEDE"/>
+                    </a:solidFill>
+                  </a:tcPr>
+                </a:tc>
+                <a:tc>
+                  <a:txBody>
+                    <a:bodyPr/>
+                    <a:lstStyle/>
+                    <a:p>
+                      <a:r>
+                        <a:rPr sz="1100"/>
+                        <a:t>-544</a:t>
+                      </a:r>
+                    </a:p>
+                  </a:txBody>
+                  <a:tcPr/>
+                </a:tc>
+                <a:tc>
+                  <a:txBody>
+                    <a:bodyPr/>
+                    <a:lstStyle/>
+                    <a:p>
+                      <a:r>
+                        <a:rPr sz="1100"/>
+                        <a:t>1.71</a:t>
+                      </a:r>
+                    </a:p>
+                  </a:txBody>
+                  <a:tcPr/>
+                </a:tc>
+                <a:tc>
+                  <a:txBody>
+                    <a:bodyPr/>
+                    <a:lstStyle/>
+                    <a:p>
+                      <a:r>
+                        <a:rPr sz="1100"/>
+                        <a:t>-371</a:t>
+                      </a:r>
+                    </a:p>
+                  </a:txBody>
+                  <a:tcPr/>
+                </a:tc>
+              </a:tr>
+              <a:tr h="240631">
+                <a:tc>
+                  <a:txBody>
+                    <a:bodyPr/>
+                    <a:lstStyle/>
+                    <a:p>
+                      <a:r>
+                        <a:rPr sz="1100"/>
+                        <a:t>LQD</a:t>
+                      </a:r>
+                    </a:p>
+                  </a:txBody>
+                  <a:tcPr/>
+                </a:tc>
+                <a:tc>
+                  <a:txBody>
+                    <a:bodyPr/>
+                    <a:lstStyle/>
+                    <a:p>
+                      <a:r>
+                        <a:rPr sz="1100"/>
+                        <a:t>2022-06-30</a:t>
+                      </a:r>
+                    </a:p>
+                  </a:txBody>
+                  <a:tcPr/>
+                </a:tc>
+                <a:tc>
+                  <a:txBody>
+                    <a:bodyPr/>
+                    <a:lstStyle/>
+                    <a:p>
+                      <a:r>
+                        <a:rPr sz="1100"/>
+                        <a:t>extremo</a:t>
+                      </a:r>
+                    </a:p>
+                  </a:txBody>
+                  <a:tcPr/>
+                </a:tc>
+                <a:tc>
+                  <a:txBody>
+                    <a:bodyPr/>
+                    <a:lstStyle/>
+                    <a:p>
+                      <a:r>
+                        <a:rPr sz="1100"/>
+                        <a:t>NEGATIVA fuerte</a:t>
+                      </a:r>
+                    </a:p>
+                  </a:txBody>
+                  <a:tcPr>
+                    <a:solidFill>
+                      <a:srgbClr val="F6DEDE"/>
+                    </a:solidFill>
+                  </a:tcPr>
+                </a:tc>
+                <a:tc>
+                  <a:txBody>
+                    <a:bodyPr/>
+                    <a:lstStyle/>
+                    <a:p>
+                      <a:r>
+                        <a:rPr sz="1100"/>
+                        <a:t>-612</a:t>
+                      </a:r>
+                    </a:p>
+                  </a:txBody>
+                  <a:tcPr/>
+                </a:tc>
+                <a:tc>
+                  <a:txBody>
+                    <a:bodyPr/>
+                    <a:lstStyle/>
+                    <a:p>
+                      <a:r>
+                        <a:rPr sz="1100"/>
+                        <a:t>1.39</a:t>
+                      </a:r>
+                    </a:p>
+                  </a:txBody>
+                  <a:tcPr/>
+                </a:tc>
+                <a:tc>
+                  <a:txBody>
+                    <a:bodyPr/>
+                    <a:lstStyle/>
+                    <a:p>
+                      <a:r>
+                        <a:rPr sz="1100"/>
+                        <a:t>-1369</a:t>
+                      </a:r>
+                    </a:p>
+                  </a:txBody>
+                  <a:tcPr/>
+                </a:tc>
+              </a:tr>
+              <a:tr h="240631">
+                <a:tc>
+                  <a:txBody>
+                    <a:bodyPr/>
+                    <a:lstStyle/>
+                    <a:p>
+                      <a:r>
+                        <a:rPr sz="1100"/>
+                        <a:t>IGOV</a:t>
+                      </a:r>
+                    </a:p>
+                  </a:txBody>
+                  <a:tcPr/>
+                </a:tc>
+                <a:tc>
+                  <a:txBody>
+                    <a:bodyPr/>
+                    <a:lstStyle/>
+                    <a:p>
+                      <a:r>
+                        <a:rPr sz="1100"/>
+                        <a:t>2022-06-30</a:t>
+                      </a:r>
+                    </a:p>
+                  </a:txBody>
+                  <a:tcPr/>
+                </a:tc>
+                <a:tc>
+                  <a:txBody>
+                    <a:bodyPr/>
+                    <a:lstStyle/>
+                    <a:p>
+                      <a:r>
+                        <a:rPr sz="1100"/>
+                        <a:t>extremo</a:t>
+                      </a:r>
+                    </a:p>
+                  </a:txBody>
+                  <a:tcPr/>
+                </a:tc>
+                <a:tc>
+                  <a:txBody>
+                    <a:bodyPr/>
+                    <a:lstStyle/>
+                    <a:p>
+                      <a:r>
+                        <a:rPr sz="1100"/>
+                        <a:t>NEGATIVA fuerte</a:t>
+                      </a:r>
+                    </a:p>
+                  </a:txBody>
+                  <a:tcPr>
+                    <a:solidFill>
+                      <a:srgbClr val="F6DEDE"/>
+                    </a:solidFill>
+                  </a:tcPr>
+                </a:tc>
+                <a:tc>
+                  <a:txBody>
+                    <a:bodyPr/>
+                    <a:lstStyle/>
+                    <a:p>
+                      <a:r>
+                        <a:rPr sz="1100"/>
+                        <a:t>-668</a:t>
+                      </a:r>
+                    </a:p>
+                  </a:txBody>
+                  <a:tcPr/>
+                </a:tc>
+                <a:tc>
+                  <a:txBody>
+                    <a:bodyPr/>
+                    <a:lstStyle/>
+                    <a:p>
+                      <a:r>
+                        <a:rPr sz="1100"/>
+                        <a:t>1.19</a:t>
+                      </a:r>
+                    </a:p>
+                  </a:txBody>
+                  <a:tcPr/>
+                </a:tc>
+                <a:tc>
+                  <a:txBody>
+                    <a:bodyPr/>
+                    <a:lstStyle/>
+                    <a:p>
+                      <a:r>
+                        <a:rPr sz="1100"/>
+                        <a:t>-1282</a:t>
+                      </a:r>
+                    </a:p>
+                  </a:txBody>
+                  <a:tcPr/>
+                </a:tc>
+              </a:tr>
+              <a:tr h="240631">
+                <a:tc>
+                  <a:txBody>
+                    <a:bodyPr/>
+                    <a:lstStyle/>
+                    <a:p>
+                      <a:r>
+                        <a:rPr sz="1100"/>
+                        <a:t>GHYG</a:t>
+                      </a:r>
+                    </a:p>
+                  </a:txBody>
+                  <a:tcPr/>
+                </a:tc>
+                <a:tc>
+                  <a:txBody>
+                    <a:bodyPr/>
+                    <a:lstStyle/>
+                    <a:p>
+                      <a:r>
+                        <a:rPr sz="1100"/>
+                        <a:t>2022-06-30</a:t>
+                      </a:r>
+                    </a:p>
+                  </a:txBody>
+                  <a:tcPr/>
+                </a:tc>
+                <a:tc>
+                  <a:txBody>
+                    <a:bodyPr/>
+                    <a:lstStyle/>
+                    <a:p>
+                      <a:r>
+                        <a:rPr sz="1100"/>
+                        <a:t>extremo</a:t>
+                      </a:r>
+                    </a:p>
+                  </a:txBody>
+                  <a:tcPr/>
+                </a:tc>
+                <a:tc>
+                  <a:txBody>
+                    <a:bodyPr/>
+                    <a:lstStyle/>
+                    <a:p>
+                      <a:r>
+                        <a:rPr sz="1100"/>
+                        <a:t>NEGATIVA moderada</a:t>
+                      </a:r>
+                    </a:p>
+                  </a:txBody>
+                  <a:tcPr>
+                    <a:solidFill>
+                      <a:srgbClr val="F6DEDE"/>
+                    </a:solidFill>
+                  </a:tcPr>
+                </a:tc>
+                <a:tc>
+                  <a:txBody>
+                    <a:bodyPr/>
+                    <a:lstStyle/>
+                    <a:p>
+                      <a:r>
+                        <a:rPr sz="1100"/>
+                        <a:t>-223</a:t>
+                      </a:r>
+                    </a:p>
+                  </a:txBody>
+                  <a:tcPr/>
+                </a:tc>
+                <a:tc>
+                  <a:txBody>
+                    <a:bodyPr/>
+                    <a:lstStyle/>
+                    <a:p>
+                      <a:r>
+                        <a:rPr sz="1100"/>
+                        <a:t>1.40</a:t>
+                      </a:r>
+                    </a:p>
+                  </a:txBody>
+                  <a:tcPr/>
+                </a:tc>
+                <a:tc>
+                  <a:txBody>
+                    <a:bodyPr/>
+                    <a:lstStyle/>
+                    <a:p>
+                      <a:r>
+                        <a:rPr sz="1100"/>
+                        <a:t>-1275</a:t>
+                      </a:r>
+                    </a:p>
+                  </a:txBody>
+                  <a:tcPr/>
+                </a:tc>
+              </a:tr>
+              <a:tr h="240631">
+                <a:tc>
+                  <a:txBody>
+                    <a:bodyPr/>
+                    <a:lstStyle/>
+                    <a:p>
+                      <a:r>
+                        <a:rPr sz="1100"/>
+                        <a:t>EMB</a:t>
+                      </a:r>
+                    </a:p>
+                  </a:txBody>
+                  <a:tcPr/>
+                </a:tc>
+                <a:tc>
+                  <a:txBody>
+                    <a:bodyPr/>
+                    <a:lstStyle/>
+                    <a:p>
+                      <a:r>
+                        <a:rPr sz="1100"/>
+                        <a:t>2022-06-30</a:t>
+                      </a:r>
+                    </a:p>
+                  </a:txBody>
+                  <a:tcPr/>
+                </a:tc>
+                <a:tc>
+                  <a:txBody>
+                    <a:bodyPr/>
+                    <a:lstStyle/>
+                    <a:p>
+                      <a:r>
+                        <a:rPr sz="1100"/>
+                        <a:t>extremo</a:t>
+                      </a:r>
+                    </a:p>
+                  </a:txBody>
+                  <a:tcPr/>
+                </a:tc>
+                <a:tc>
+                  <a:txBody>
+                    <a:bodyPr/>
+                    <a:lstStyle/>
+                    <a:p>
+                      <a:r>
+                        <a:rPr sz="1100"/>
+                        <a:t>NEGATIVA fuerte</a:t>
+                      </a:r>
+                    </a:p>
+                  </a:txBody>
+                  <a:tcPr>
+                    <a:solidFill>
+                      <a:srgbClr val="F6DEDE"/>
+                    </a:solidFill>
+                  </a:tcPr>
+                </a:tc>
+                <a:tc>
+                  <a:txBody>
+                    <a:bodyPr/>
+                    <a:lstStyle/>
+                    <a:p>
+                      <a:r>
+                        <a:rPr sz="1100"/>
+                        <a:t>-376</a:t>
+                      </a:r>
+                    </a:p>
+                  </a:txBody>
+                  <a:tcPr/>
+                </a:tc>
+                <a:tc>
+                  <a:txBody>
+                    <a:bodyPr/>
+                    <a:lstStyle/>
+                    <a:p>
+                      <a:r>
+                        <a:rPr sz="1100"/>
+                        <a:t>1.56</a:t>
+                      </a:r>
+                    </a:p>
+                  </a:txBody>
+                  <a:tcPr/>
+                </a:tc>
+                <a:tc>
+                  <a:txBody>
+                    <a:bodyPr/>
+                    <a:lstStyle/>
+                    <a:p>
+                      <a:r>
+                        <a:rPr sz="1100"/>
+                        <a:t>-1338</a:t>
+                      </a:r>
+                    </a:p>
+                  </a:txBody>
+                  <a:tcPr/>
+                </a:tc>
+              </a:tr>
+              <a:tr h="240631">
+                <a:tc>
+                  <a:txBody>
+                    <a:bodyPr/>
+                    <a:lstStyle/>
+                    <a:p>
+                      <a:r>
+                        <a:rPr sz="1100"/>
+                        <a:t>ACWI</a:t>
+                      </a:r>
+                    </a:p>
+                  </a:txBody>
+                  <a:tcPr/>
+                </a:tc>
+                <a:tc>
+                  <a:txBody>
+                    <a:bodyPr/>
+                    <a:lstStyle/>
+                    <a:p>
+                      <a:r>
+                        <a:rPr sz="1100"/>
+                        <a:t>2022-06-30</a:t>
+                      </a:r>
+                    </a:p>
+                  </a:txBody>
+                  <a:tcPr/>
+                </a:tc>
+                <a:tc>
+                  <a:txBody>
+                    <a:bodyPr/>
+                    <a:lstStyle/>
+                    <a:p>
+                      <a:r>
+                        <a:rPr sz="1100"/>
+                        <a:t>extremo</a:t>
+                      </a:r>
+                    </a:p>
+                  </a:txBody>
+                  <a:tcPr/>
+                </a:tc>
+                <a:tc>
+                  <a:txBody>
+                    <a:bodyPr/>
+                    <a:lstStyle/>
+                    <a:p>
+                      <a:r>
+                        <a:rPr sz="1100"/>
+                        <a:t>NEGATIVA fuerte</a:t>
+                      </a:r>
+                    </a:p>
+                  </a:txBody>
+                  <a:tcPr>
+                    <a:solidFill>
+                      <a:srgbClr val="F6DEDE"/>
+                    </a:solidFill>
+                  </a:tcPr>
+                </a:tc>
+                <a:tc>
+                  <a:txBody>
+                    <a:bodyPr/>
+                    <a:lstStyle/>
+                    <a:p>
+                      <a:r>
+                        <a:rPr sz="1100"/>
+                        <a:t>-708</a:t>
+                      </a:r>
+                    </a:p>
+                  </a:txBody>
+                  <a:tcPr/>
+                </a:tc>
+                <a:tc>
+                  <a:txBody>
+                    <a:bodyPr/>
+                    <a:lstStyle/>
+                    <a:p>
+                      <a:r>
+                        <a:rPr sz="1100"/>
+                        <a:t>0.97</a:t>
+                      </a:r>
+                    </a:p>
+                  </a:txBody>
+                  <a:tcPr/>
+                </a:tc>
+                <a:tc>
+                  <a:txBody>
+                    <a:bodyPr/>
+                    <a:lstStyle/>
+                    <a:p>
+                      <a:r>
+                        <a:rPr sz="1100"/>
+                        <a:t>-1847</a:t>
+                      </a:r>
+                    </a:p>
+                  </a:txBody>
+                  <a:tcPr/>
+                </a:tc>
+              </a:tr>
+              <a:tr h="240631">
+                <a:tc>
+                  <a:txBody>
+                    <a:bodyPr/>
+                    <a:lstStyle/>
+                    <a:p>
+                      <a:r>
+                        <a:rPr sz="1100"/>
+                        <a:t>Portafolio LUZ</a:t>
+                      </a:r>
+                    </a:p>
+                  </a:txBody>
+                  <a:tcPr/>
+                </a:tc>
+                <a:tc>
+                  <a:txBody>
+                    <a:bodyPr/>
+                    <a:lstStyle/>
+                    <a:p>
+                      <a:r>
+                        <a:rPr sz="1100"/>
+                        <a:t>2022-03-31</a:t>
+                      </a:r>
+                    </a:p>
+                  </a:txBody>
+                  <a:tcPr/>
+                </a:tc>
+                <a:tc>
+                  <a:txBody>
+                    <a:bodyPr/>
+                    <a:lstStyle/>
+                    <a:p>
+                      <a:r>
+                        <a:rPr sz="1100"/>
+                        <a:t>cola_gorda</a:t>
+                      </a:r>
+                    </a:p>
+                  </a:txBody>
+                  <a:tcPr/>
+                </a:tc>
+                <a:tc>
+                  <a:txBody>
+                    <a:bodyPr/>
+                    <a:lstStyle/>
+                    <a:p>
+                      <a:r>
+                        <a:rPr sz="1100"/>
+                        <a:t>NEGATIVA fuerte</a:t>
+                      </a:r>
+                    </a:p>
+                  </a:txBody>
+                  <a:tcPr>
+                    <a:solidFill>
+                      <a:srgbClr val="F6DEDE"/>
+                    </a:solidFill>
+                  </a:tcPr>
+                </a:tc>
+                <a:tc>
+                  <a:txBody>
+                    <a:bodyPr/>
+                    <a:lstStyle/>
+                    <a:p>
+                      <a:r>
+                        <a:rPr sz="1100"/>
+                        <a:t>-401</a:t>
+                      </a:r>
+                    </a:p>
+                  </a:txBody>
+                  <a:tcPr/>
+                </a:tc>
+                <a:tc>
+                  <a:txBody>
+                    <a:bodyPr/>
+                    <a:lstStyle/>
+                    <a:p>
+                      <a:r>
+                        <a:rPr sz="1100"/>
+                        <a:t>1.38</a:t>
+                      </a:r>
+                    </a:p>
+                  </a:txBody>
+                  <a:tcPr/>
+                </a:tc>
+                <a:tc>
+                  <a:txBody>
+                    <a:bodyPr/>
+                    <a:lstStyle/>
+                    <a:p>
+                      <a:r>
+                        <a:rPr sz="1100"/>
+                        <a:t>-690</a:t>
+                      </a:r>
+                    </a:p>
+                  </a:txBody>
+                  <a:tcPr/>
+                </a:tc>
+              </a:tr>
+              <a:tr h="240631">
+                <a:tc>
+                  <a:txBody>
+                    <a:bodyPr/>
+                    <a:lstStyle/>
+                    <a:p>
+                      <a:r>
+                        <a:rPr sz="1100"/>
+                        <a:t>LQD</a:t>
+                      </a:r>
+                    </a:p>
+                  </a:txBody>
+                  <a:tcPr/>
+                </a:tc>
+                <a:tc>
+                  <a:txBody>
+                    <a:bodyPr/>
+                    <a:lstStyle/>
+                    <a:p>
+                      <a:r>
+                        <a:rPr sz="1100"/>
+                        <a:t>2022-03-31</a:t>
+                      </a:r>
+                    </a:p>
+                  </a:txBody>
+                  <a:tcPr/>
+                </a:tc>
+                <a:tc>
+                  <a:txBody>
+                    <a:bodyPr/>
+                    <a:lstStyle/>
+                    <a:p>
+                      <a:r>
+                        <a:rPr sz="1100"/>
+                        <a:t>cola_gorda</a:t>
+                      </a:r>
+                    </a:p>
+                  </a:txBody>
+                  <a:tcPr/>
+                </a:tc>
+                <a:tc>
+                  <a:txBody>
+                    <a:bodyPr/>
+                    <a:lstStyle/>
+                    <a:p>
+                      <a:r>
+                        <a:rPr sz="1100"/>
+                        <a:t>NEGATIVA fuerte</a:t>
+                      </a:r>
+                    </a:p>
+                  </a:txBody>
+                  <a:tcPr>
+                    <a:solidFill>
+                      <a:srgbClr val="F6DEDE"/>
+                    </a:solidFill>
+                  </a:tcPr>
+                </a:tc>
+                <a:tc>
+                  <a:txBody>
+                    <a:bodyPr/>
+                    <a:lstStyle/>
+                    <a:p>
+                      <a:r>
+                        <a:rPr sz="1100"/>
+                        <a:t>-504</a:t>
+                      </a:r>
+                    </a:p>
+                  </a:txBody>
+                  <a:tcPr/>
+                </a:tc>
+                <a:tc>
+                  <a:txBody>
+                    <a:bodyPr/>
+                    <a:lstStyle/>
+                    <a:p>
+                      <a:r>
+                        <a:rPr sz="1100"/>
+                        <a:t>1.14</a:t>
+                      </a:r>
+                    </a:p>
+                  </a:txBody>
+                  <a:tcPr/>
+                </a:tc>
+                <a:tc>
+                  <a:txBody>
+                    <a:bodyPr/>
+                    <a:lstStyle/>
+                    <a:p>
+                      <a:r>
+                        <a:rPr sz="1100"/>
+                        <a:t>-1012</a:t>
+                      </a:r>
+                    </a:p>
+                  </a:txBody>
+                  <a:tcPr/>
+                </a:tc>
+              </a:tr>
+              <a:tr h="240631">
+                <a:tc>
+                  <a:txBody>
+                    <a:bodyPr/>
+                    <a:lstStyle/>
+                    <a:p>
+                      <a:r>
+                        <a:rPr sz="1100"/>
+                        <a:t>IGOV</a:t>
+                      </a:r>
+                    </a:p>
+                  </a:txBody>
+                  <a:tcPr/>
+                </a:tc>
+                <a:tc>
+                  <a:txBody>
+                    <a:bodyPr/>
+                    <a:lstStyle/>
+                    <a:p>
+                      <a:r>
+                        <a:rPr sz="1100"/>
+                        <a:t>2022-03-31</a:t>
+                      </a:r>
+                    </a:p>
+                  </a:txBody>
+                  <a:tcPr/>
+                </a:tc>
+                <a:tc>
+                  <a:txBody>
+                    <a:bodyPr/>
+                    <a:lstStyle/>
+                    <a:p>
+                      <a:r>
+                        <a:rPr sz="1100"/>
+                        <a:t>cola_gorda</a:t>
+                      </a:r>
+                    </a:p>
+                  </a:txBody>
+                  <a:tcPr/>
+                </a:tc>
+                <a:tc>
+                  <a:txBody>
+                    <a:bodyPr/>
+                    <a:lstStyle/>
+                    <a:p>
+                      <a:r>
+                        <a:rPr sz="1100"/>
+                        <a:t>NEGATIVA fuerte</a:t>
+                      </a:r>
+                    </a:p>
+                  </a:txBody>
+                  <a:tcPr>
+                    <a:solidFill>
+                      <a:srgbClr val="F6DEDE"/>
+                    </a:solidFill>
+                  </a:tcPr>
+                </a:tc>
+                <a:tc>
+                  <a:txBody>
+                    <a:bodyPr/>
+                    <a:lstStyle/>
+                    <a:p>
+                      <a:r>
+                        <a:rPr sz="1100"/>
+                        <a:t>-560</a:t>
+                      </a:r>
+                    </a:p>
+                  </a:txBody>
+                  <a:tcPr/>
+                </a:tc>
+                <a:tc>
+                  <a:txBody>
+                    <a:bodyPr/>
+                    <a:lstStyle/>
+                    <a:p>
+                      <a:r>
+                        <a:rPr sz="1100"/>
+                        <a:t>1.18</a:t>
+                      </a:r>
+                    </a:p>
+                  </a:txBody>
+                  <a:tcPr/>
+                </a:tc>
+                <a:tc>
+                  <a:txBody>
+                    <a:bodyPr/>
+                    <a:lstStyle/>
+                    <a:p>
+                      <a:r>
+                        <a:rPr sz="1100"/>
+                        <a:t>-874</a:t>
+                      </a:r>
+                    </a:p>
+                  </a:txBody>
+                  <a:tcPr/>
+                </a:tc>
+              </a:tr>
+              <a:tr h="240631">
+                <a:tc>
+                  <a:txBody>
+                    <a:bodyPr/>
+                    <a:lstStyle/>
+                    <a:p>
+                      <a:r>
+                        <a:rPr sz="1100"/>
+                        <a:t>GHYG</a:t>
+                      </a:r>
+                    </a:p>
+                  </a:txBody>
+                  <a:tcPr/>
+                </a:tc>
+                <a:tc>
+                  <a:txBody>
+                    <a:bodyPr/>
+                    <a:lstStyle/>
+                    <a:p>
+                      <a:r>
+                        <a:rPr sz="1100"/>
+                        <a:t>2022-03-31</a:t>
+                      </a:r>
+                    </a:p>
+                  </a:txBody>
+                  <a:tcPr/>
+                </a:tc>
+                <a:tc>
+                  <a:txBody>
+                    <a:bodyPr/>
+                    <a:lstStyle/>
+                    <a:p>
+                      <a:r>
+                        <a:rPr sz="1100"/>
+                        <a:t>cola_gorda</a:t>
+                      </a:r>
+                    </a:p>
+                  </a:txBody>
+                  <a:tcPr/>
+                </a:tc>
+                <a:tc>
+                  <a:txBody>
+                    <a:bodyPr/>
+                    <a:lstStyle/>
+                    <a:p>
+                      <a:r>
+                        <a:rPr sz="1100"/>
+                        <a:t>NEGATIVA moderada</a:t>
+                      </a:r>
+                    </a:p>
+                  </a:txBody>
+                  <a:tcPr>
+                    <a:solidFill>
+                      <a:srgbClr val="F6DEDE"/>
+                    </a:solidFill>
+                  </a:tcPr>
+                </a:tc>
+                <a:tc>
+                  <a:txBody>
+                    <a:bodyPr/>
+                    <a:lstStyle/>
+                    <a:p>
+                      <a:r>
+                        <a:rPr sz="1100"/>
+                        <a:t>-237</a:t>
+                      </a:r>
+                    </a:p>
+                  </a:txBody>
+                  <a:tcPr/>
+                </a:tc>
+                <a:tc>
+                  <a:txBody>
+                    <a:bodyPr/>
+                    <a:lstStyle/>
+                    <a:p>
+                      <a:r>
+                        <a:rPr sz="1100"/>
+                        <a:t>1.26</a:t>
+                      </a:r>
+                    </a:p>
+                  </a:txBody>
+                  <a:tcPr/>
+                </a:tc>
+                <a:tc>
+                  <a:txBody>
+                    <a:bodyPr/>
+                    <a:lstStyle/>
+                    <a:p>
+                      <a:r>
+                        <a:rPr sz="1100"/>
+                        <a:t>-634</a:t>
+                      </a:r>
+                    </a:p>
+                  </a:txBody>
+                  <a:tcPr/>
+                </a:tc>
+              </a:tr>
+              <a:tr h="240631">
+                <a:tc>
+                  <a:txBody>
+                    <a:bodyPr/>
+                    <a:lstStyle/>
+                    <a:p>
+                      <a:r>
+                        <a:rPr sz="1100"/>
+                        <a:t>EMB</a:t>
+                      </a:r>
+                    </a:p>
+                  </a:txBody>
+                  <a:tcPr/>
+                </a:tc>
+                <a:tc>
+                  <a:txBody>
+                    <a:bodyPr/>
+                    <a:lstStyle/>
+                    <a:p>
+                      <a:r>
+                        <a:rPr sz="1100"/>
+                        <a:t>2022-03-31</a:t>
+                      </a:r>
+                    </a:p>
+                  </a:txBody>
+                  <a:tcPr/>
+                </a:tc>
+                <a:tc>
+                  <a:txBody>
+                    <a:bodyPr/>
+                    <a:lstStyle/>
+                    <a:p>
+                      <a:r>
+                        <a:rPr sz="1100"/>
+                        <a:t>cola_gorda</a:t>
+                      </a:r>
+                    </a:p>
+                  </a:txBody>
+                  <a:tcPr/>
+                </a:tc>
+                <a:tc>
+                  <a:txBody>
+                    <a:bodyPr/>
+                    <a:lstStyle/>
+                    <a:p>
+                      <a:r>
+                        <a:rPr sz="1100"/>
+                        <a:t>NEGATIVA moderada</a:t>
+                      </a:r>
+                    </a:p>
+                  </a:txBody>
+                  <a:tcPr>
+                    <a:solidFill>
+                      <a:srgbClr val="F6DEDE"/>
+                    </a:solidFill>
+                  </a:tcPr>
+                </a:tc>
+                <a:tc>
+                  <a:txBody>
+                    <a:bodyPr/>
+                    <a:lstStyle/>
+                    <a:p>
+                      <a:r>
+                        <a:rPr sz="1100"/>
+                        <a:t>-262</a:t>
+                      </a:r>
+                    </a:p>
+                  </a:txBody>
+                  <a:tcPr/>
+                </a:tc>
+                <a:tc>
+                  <a:txBody>
+                    <a:bodyPr/>
+                    <a:lstStyle/>
+                    <a:p>
+                      <a:r>
+                        <a:rPr sz="1100"/>
+                        <a:t>1.19</a:t>
+                      </a:r>
+                    </a:p>
+                  </a:txBody>
+                  <a:tcPr/>
+                </a:tc>
+                <a:tc>
+                  <a:txBody>
+                    <a:bodyPr/>
+                    <a:lstStyle/>
+                    <a:p>
+                      <a:r>
+                        <a:rPr sz="1100"/>
+                        <a:t>-1446</a:t>
+                      </a:r>
+                    </a:p>
+                  </a:txBody>
+                  <a:tcPr/>
+                </a:tc>
+              </a:tr>
+              <a:tr h="240642">
+                <a:tc>
+                  <a:txBody>
+                    <a:bodyPr/>
+                    <a:lstStyle/>
+                    <a:p>
+                      <a:r>
+                        <a:rPr sz="1100"/>
+                        <a:t>ACWI</a:t>
+                      </a:r>
+                    </a:p>
+                  </a:txBody>
+                  <a:tcPr/>
+                </a:tc>
+                <a:tc>
+                  <a:txBody>
+                    <a:bodyPr/>
+                    <a:lstStyle/>
+                    <a:p>
+                      <a:r>
+                        <a:rPr sz="1100"/>
+                        <a:t>2022-03-31</a:t>
+                      </a:r>
+                    </a:p>
+                  </a:txBody>
+                  <a:tcPr/>
+                </a:tc>
+                <a:tc>
+                  <a:txBody>
+                    <a:bodyPr/>
+                    <a:lstStyle/>
+                    <a:p>
+                      <a:r>
+                        <a:rPr sz="1100"/>
+                        <a:t>cola_gorda</a:t>
+                      </a:r>
+                    </a:p>
+                  </a:txBody>
+                  <a:tcPr/>
+                </a:tc>
+                <a:tc>
+                  <a:txBody>
+                    <a:bodyPr/>
+                    <a:lstStyle/>
+                    <a:p>
+                      <a:r>
+                        <a:rPr sz="1100"/>
+                        <a:t>NEGATIVA fuerte</a:t>
+                      </a:r>
+                    </a:p>
+                  </a:txBody>
+                  <a:tcPr>
+                    <a:solidFill>
+                      <a:srgbClr val="F6DEDE"/>
+                    </a:solidFill>
+                  </a:tcPr>
+                </a:tc>
+                <a:tc>
+                  <a:txBody>
+                    <a:bodyPr/>
+                    <a:lstStyle/>
+                    <a:p>
+                      <a:r>
+                        <a:rPr sz="1100"/>
+                        <a:t>-673</a:t>
+                      </a:r>
+                    </a:p>
+                  </a:txBody>
+                  <a:tcPr/>
+                </a:tc>
+                <a:tc>
+                  <a:txBody>
+                    <a:bodyPr/>
+                    <a:lstStyle/>
+                    <a:p>
+                      <a:r>
+                        <a:rPr sz="1100"/>
+                        <a:t>1.06</a:t>
+                      </a:r>
+                    </a:p>
+                  </a:txBody>
+                  <a:tcPr/>
+                </a:tc>
+                <a:tc>
+                  <a:txBody>
+                    <a:bodyPr/>
+                    <a:lstStyle/>
+                    <a:p>
+                      <a:r>
+                        <a:rPr sz="1100"/>
+                        <a:t>-1103</a:t>
+                      </a:r>
+                    </a:p>
+                  </a:txBody>
+                  <a:tcPr/>
+                </a:tc>
+              </a:tr>
+            </a:tbl>
+          </a:graphicData>
+        </a:graphic>
+      </p:graphicFrame>
+      <p:sp>
+        <p:nvSpPr>
+          <p:cNvPr id="4" name="TextBox 3"/>
+          <p:cNvSpPr txBox="1"/>
+          <p:nvPr/>
+        </p:nvSpPr>
+        <p:spPr>
+          <a:xfrm>
+            <a:off x="640080" y="6309360"/>
+            <a:ext cx="10908792" cy="365760"/>
+          </a:xfrm>
+          <a:prstGeom prst="rect">
+            <a:avLst/>
+          </a:prstGeom>
+          <a:noFill/>
+        </p:spPr>
+        <p:txBody>
+          <a:bodyPr wrap="square">
+            <a:spAutoFit/>
+          </a:bodyPr>
+          <a:lstStyle/>
+          <a:p>
+            <a:pPr algn="l"/>
+            <a:r>
+              <a:rPr sz="900" b="0" i="1">
+                <a:solidFill>
+                  <a:srgbClr val="666666"/>
+                </a:solidFill>
+              </a:rPr>
+              <a:t>Documento informativo con fines analíticos. No constituye recomendación de inversión.</a:t>
+            </a:r>
+          </a:p>
+        </p:txBody>
+      </p:sp>
+    </p:spTree>
+  </p:cSld>
+  <p:clrMapOvr>
+    <a:masterClrMapping/>
+  </p:clrMapOvr>
+</p:sld>
+</file>
+
+<file path=ppt/slides/slide19.xml><?xml version="1.0" encoding="utf-8"?>
 <p:sld xmlns:a="http://schemas.openxmlformats.org/drawingml/2006/main" xmlns:p="http://schemas.openxmlformats.org/presentationml/2006/main" xmlns:r="http://schemas.openxmlformats.org/officeDocument/2006/relationships">
   <p:cSld>
     <p:spTree>
@@ -4728,14 +6887,14 @@
                   <a:srgbClr val="1A3A5C"/>
                 </a:solidFill>
               </a:rPr>
-              <a:t>Comparación portafolio · luz_portafolio_2024-06-30_h12m</a:t>
+              <a:t>Comparación portafolio · luz_portafolio_2022-03-31_h12m</a:t>
             </a:r>
           </a:p>
         </p:txBody>
       </p:sp>
       <p:pic>
         <p:nvPicPr>
-          <p:cNvPr id="3" name="Picture 2" descr="luz_portafolio_2024-06-30_h12m.png"/>
+          <p:cNvPr id="3" name="Picture 2" descr="luz_portafolio_2022-03-31_h12m.png"/>
           <p:cNvPicPr>
             <a:picLocks noChangeAspect="1"/>
           </p:cNvPicPr>
@@ -4750,7 +6909,7 @@
         <p:spPr>
           <a:xfrm>
             <a:off x="365760" y="548640"/>
-            <a:ext cx="11457432" cy="6658436"/>
+            <a:ext cx="11457432" cy="6654465"/>
           </a:xfrm>
           <a:prstGeom prst="rect">
             <a:avLst/>

</xml_diff>